<commit_message>
docs: add Week 6 to the phase review deck and correct 林崇瑋's name
The v2 deck grows to 16 slides: a Week 6 evaluator-optimizer slide with
the live comparison, and updated timeline, PDF history, test count (213)
and status board. The gpt-5.4 PDF passes are shown with their 6 of 7
business expectations and the commits that were actually measured. The
speaker script stays within 14 minutes.

The team member's name was misspelt 林崇偉; it is now 林崇瑋 in the root
README, Week 2 and 3 docs, both decks and the frozen midterm folder,
whose PPTX, PDF and overview were regenerated with only the name
changed. The midterm manifest still describes the tagged original.

Co-Authored-By: Claude Opus 5.5 <noreply@anthropic.com>
</commit_message>
<xml_diff>
--- a/reports/midterm/phase-review.pptx
+++ b/reports/midterm/phase-review.pptx
@@ -5398,7 +5398,7 @@
                 <a:ea typeface="PingFang TC"/>
                 <a:cs typeface="PingFang TC"/>
               </a:rPr>
-              <a:t>林崇偉 S11259031（隊員）</a:t>
+              <a:t>林崇瑋 S11259031（隊員）</a:t>
             </a:r>
           </a:p>
         </p:txBody>
@@ -10695,7 +10695,7 @@
                 <a:ea typeface="PingFang TC"/>
                 <a:cs typeface="PingFang TC"/>
               </a:rPr>
-              <a:t>林崇偉  S11259031</a:t>
+              <a:t>林崇瑋  S11259031</a:t>
             </a:r>
           </a:p>
         </p:txBody>

</xml_diff>